<commit_message>
Count languages strictly: 27 (Keith's 12 + 15 new), not 29 families
C/C++ and Perl/PDL count as one language each, as in Shortridge (2019),
and PyPy is a Python implementation rather than a new language. The
report footnote explains why the per-family figure still has 29 rows.
</commit_message>
<xml_diff>
--- a/talk/ADASS2026-talk.pptx
+++ b/talk/ADASS2026-talk.pptx
@@ -124,7 +124,7 @@
   <p:extLst>
     <p:ext uri="{521415D9-36F7-43E2-AB2F-B90AF26B5E84}">
       <p14:sectionLst xmlns:p14="http://schemas.microsoft.com/office/powerpoint/2010/main">
-        <p14:section name="The story" id="{a7ff3481-cbea-fbac-b2da-98050de1ff56}">
+        <p14:section name="The story" id="{5b09cb80-930f-4f91-99ef-980a178352e1}">
           <p14:sldIdLst>
             <p14:sldId id="256"/>
             <p14:sldId id="257"/>
@@ -132,7 +132,7 @@
             <p14:sldId id="259"/>
           </p14:sldIdLst>
         </p14:section>
-        <p14:section name="Results" id="{891c0c4d-6353-3db5-b2ef-c2bc99d610ee}">
+        <p14:section name="Results" id="{499ed017-bcb4-f4ba-77e6-b30eb2446753}">
           <p14:sldIdLst>
             <p14:sldId id="260"/>
             <p14:sldId id="261"/>
@@ -142,7 +142,7 @@
             <p14:sldId id="265"/>
           </p14:sldIdLst>
         </p14:section>
-        <p14:section name="The LLM" id="{6326985b-a0c6-cb03-3556-3567cc149514}">
+        <p14:section name="The LLM" id="{377a8c37-fe0b-4c8a-a9e5-117f47ea4800}">
           <p14:sldIdLst>
             <p14:sldId id="266"/>
             <p14:sldId id="267"/>
@@ -150,7 +150,7 @@
             <p14:sldId id="269"/>
           </p14:sldIdLst>
         </p14:section>
-        <p14:section name="Backup" id="{1e63c49b-f193-84a9-97ff-56aa5f05bebf}">
+        <p14:section name="Backup" id="{8b1ab0a2-279e-c964-3554-9ec888433f1e}">
           <p14:sldIdLst>
             <p14:sldId id="270"/>
             <p14:sldId id="271"/>
@@ -4703,7 +4703,7 @@
           <a:p>
             <a:r>
               <a:rPr lang="en-US" dirty="0"/>
-              <a:t>~1 min. Then Claude Code arrived and I used it to port the suite to a few more languages, for fun. Day one: 58 of 104 tests passing on this Mac. By day five, 29 families and 131 tests. My own message: 'Do #1 to #7 please and then we will stop'. We did not stop. Then the report, audits, the PDL fix and a reproducible toolchain. Prompt count is from the transcript to 30 April.</a:t>
+              <a:t>~1 min. Then Claude Code arrived and I used it to port the suite to a few more languages, for fun. Day one: 58 of 104 tests passing on this Mac. By day five, 27 languages and 131 tests. My own message: 'Do #1 to #7 please and then we will stop'. We did not stop. Then the report, audits, the PDL fix and a reproducible toolchain. Prompt count is from the transcript to 30 April.</a:t>
             </a:r>
             <a:endParaRPr lang="en-US" dirty="0"/>
           </a:p>
@@ -4791,7 +4791,7 @@
           <a:p>
             <a:r>
               <a:rPr lang="en-US" dirty="0"/>
-              <a:t>~45 s. 29 families, 131 variants, all passing in run22, the frozen reference. The range is 4.8e5 rather than Keith's million, partly from the new reference and partly the PDL correction. Most compiled languages pile up in tier 3.</a:t>
+              <a:t>~45 s. 27 languages, 15 of them new, counted the way Keith counted his 12 (C/C++ as one, Perl/PDL as one). 131 variants, all passing in run22, the frozen reference. The range is 4.8e5 rather than Keith's million, partly from the new reference and partly the PDL correction. Most compiled languages pile up in tier 3.</a:t>
             </a:r>
             <a:endParaRPr lang="en-US" dirty="0"/>
           </a:p>
@@ -10657,7 +10657,7 @@
                   <a:schemeClr val="tx1"/>
                 </a:solidFill>
               </a:rPr>
-              <a:t>16 new families in about four days, each kernel adapted to the language's idioms. J came out in 9 lines, with no hints from me.</a:t>
+              <a:t>15 new languages in about four days, each kernel adapted to the language's idioms. J came out in 9 lines, with no hints from me.</a:t>
             </a:r>
             <a:endParaRPr lang="en-US" sz="1900" dirty="0"/>
           </a:p>
@@ -34127,7 +34127,7 @@
       </p:sp>
       <p:sp>
         <p:nvSpPr>
-          <p:cNvPr id="14" name="stat language families"/>
+          <p:cNvPr id="14" name="stat languages"/>
           <p:cNvSpPr/>
           <p:nvPr/>
         </p:nvSpPr>
@@ -34185,7 +34185,7 @@
                 <a:ea typeface="+mj-lt" pitchFamily="34" charset="-122"/>
                 <a:cs typeface="+mj-lt" pitchFamily="34" charset="-120"/>
               </a:rPr>
-              <a:t>29</a:t>
+              <a:t>27</a:t>
             </a:r>
             <a:endParaRPr lang="en-US" sz="3000" dirty="0"/>
           </a:p>
@@ -34221,7 +34221,7 @@
                   <a:srgbClr val="5A6275"/>
                 </a:solidFill>
               </a:rPr>
-              <a:t>language families</a:t>
+              <a:t>languages</a:t>
             </a:r>
             <a:endParaRPr lang="en-US" sz="1200" dirty="0"/>
           </a:p>
@@ -34580,7 +34580,7 @@
                 <a:ea typeface="+mj-lt" pitchFamily="34" charset="-122"/>
                 <a:cs typeface="+mj-lt" pitchFamily="34" charset="-120"/>
               </a:rPr>
-              <a:t>29</a:t>
+              <a:t>27</a:t>
             </a:r>
             <a:endParaRPr lang="en-US" sz="4800" dirty="0"/>
           </a:p>
@@ -34616,7 +34616,7 @@
                   <a:schemeClr val="tx1"/>
                 </a:solidFill>
               </a:rPr>
-              <a:t>language families</a:t>
+              <a:t>languages</a:t>
             </a:r>
             <a:endParaRPr lang="en-US" sz="1600" dirty="0"/>
           </a:p>
@@ -34630,7 +34630,7 @@
                   <a:srgbClr val="5A6275"/>
                 </a:solidFill>
               </a:rPr>
-              <a:t>16 new since 2019</a:t>
+              <a:t>15 new since 2019</a:t>
             </a:r>
             <a:endParaRPr lang="en-US" sz="1600" dirty="0"/>
           </a:p>

</xml_diff>